<commit_message>
Set June-26 title slide topic to using AI correctly in real projects.
Co-authored-by: Cursor <cursoragent@cursor.com>
</commit_message>
<xml_diff>
--- a/slides/June-26.pptx
+++ b/slides/June-26.pptx
@@ -3268,25 +3268,25 @@
           <a:p>
             <a:pPr algn="l"/>
             <a:r>
-              <a:rPr sz="4000" b="0">
+              <a:rPr sz="4000">
                 <a:solidFill>
                   <a:srgbClr val="0F2740"/>
                 </a:solidFill>
                 <a:latin typeface="Arial Black"/>
               </a:rPr>
-              <a:t>Topic</a:t>
+              <a:t>How to Use AI Correctly</a:t>
             </a:r>
           </a:p>
           <a:p>
             <a:pPr algn="l"/>
             <a:r>
-              <a:rPr sz="4000" b="0">
+              <a:rPr sz="4000">
                 <a:solidFill>
                   <a:srgbClr val="0F2740"/>
                 </a:solidFill>
                 <a:latin typeface="Arial Black"/>
               </a:rPr>
-              <a:t>TBD</a:t>
+              <a:t>In a Real Project</a:t>
             </a:r>
           </a:p>
         </p:txBody>
@@ -3321,7 +3321,25 @@
                 </a:solidFill>
                 <a:latin typeface="Calibri"/>
               </a:rPr>
-              <a:t>Fill in today's session focus before class.</a:t>
+              <a:t>Prompts are easy — </a:t>
+            </a:r>
+            <a:r>
+              <a:rPr sz="1700" b="1">
+                <a:solidFill>
+                  <a:srgbClr val="F97316"/>
+                </a:solidFill>
+                <a:latin typeface="Calibri"/>
+              </a:rPr>
+              <a:t>real projects</a:t>
+            </a:r>
+            <a:r>
+              <a:rPr sz="1700" b="0">
+                <a:solidFill>
+                  <a:srgbClr val="47566B"/>
+                </a:solidFill>
+                <a:latin typeface="Calibri"/>
+              </a:rPr>
+              <a:t> need plans, tests, and review.</a:t>
             </a:r>
           </a:p>
         </p:txBody>

</xml_diff>

<commit_message>
Add slide 2 on common prompt-only AI workflow and its limits.
Co-authored-by: Cursor <cursoragent@cursor.com>
</commit_message>
<xml_diff>
--- a/slides/June-26.pptx
+++ b/slides/June-26.pptx
@@ -6,6 +6,7 @@
   </p:sldMasterIdLst>
   <p:sldIdLst>
     <p:sldId id="256" r:id="rId7"/>
+    <p:sldId id="257" r:id="rId8"/>
   </p:sldIdLst>
   <p:sldSz cx="12191695" cy="6858000" type="screen4x3"/>
   <p:notesSz cx="6858000" cy="9144000"/>
@@ -3516,6 +3517,585 @@
           <a:lstStyle/>
           <a:p>
             <a:pPr algn="ctr"/>
+          </a:p>
+        </p:txBody>
+      </p:sp>
+    </p:spTree>
+  </p:cSld>
+  <p:clrMapOvr>
+    <a:masterClrMapping/>
+  </p:clrMapOvr>
+</p:sld>
+</file>
+
+<file path=ppt/slides/slide2.xml><?xml version="1.0" encoding="utf-8"?>
+<p:sld xmlns:a="http://schemas.openxmlformats.org/drawingml/2006/main" xmlns:p="http://schemas.openxmlformats.org/presentationml/2006/main" xmlns:r="http://schemas.openxmlformats.org/officeDocument/2006/relationships">
+  <p:cSld>
+    <p:spTree>
+      <p:nvGrpSpPr>
+        <p:cNvPr id="1" name=""/>
+        <p:cNvGrpSpPr/>
+        <p:nvPr/>
+      </p:nvGrpSpPr>
+      <p:grpSpPr/>
+      <p:sp>
+        <p:nvSpPr>
+          <p:cNvPr id="2" name="Rectangle 1"/>
+          <p:cNvSpPr/>
+          <p:nvPr/>
+        </p:nvSpPr>
+        <p:spPr>
+          <a:xfrm>
+            <a:off x="0" y="0"/>
+            <a:ext cx="12191695" cy="6858000"/>
+          </a:xfrm>
+          <a:prstGeom prst="rect">
+            <a:avLst/>
+          </a:prstGeom>
+          <a:solidFill>
+            <a:srgbClr val="F4F8FC"/>
+          </a:solidFill>
+          <a:ln>
+            <a:noFill/>
+          </a:ln>
+        </p:spPr>
+        <p:style>
+          <a:lnRef idx="1">
+            <a:schemeClr val="accent1"/>
+          </a:lnRef>
+          <a:fillRef idx="3">
+            <a:schemeClr val="accent1"/>
+          </a:fillRef>
+          <a:effectRef idx="2">
+            <a:schemeClr val="accent1"/>
+          </a:effectRef>
+          <a:fontRef idx="minor">
+            <a:schemeClr val="lt1"/>
+          </a:fontRef>
+        </p:style>
+        <p:txBody>
+          <a:bodyPr rtlCol="0" anchor="ctr"/>
+          <a:lstStyle/>
+          <a:p>
+            <a:pPr algn="ctr"/>
+          </a:p>
+        </p:txBody>
+      </p:sp>
+      <p:sp>
+        <p:nvSpPr>
+          <p:cNvPr id="3" name="Rectangle 2"/>
+          <p:cNvSpPr/>
+          <p:nvPr/>
+        </p:nvSpPr>
+        <p:spPr>
+          <a:xfrm>
+            <a:off x="11475720" y="384048"/>
+            <a:ext cx="118872" cy="118872"/>
+          </a:xfrm>
+          <a:prstGeom prst="rect">
+            <a:avLst/>
+          </a:prstGeom>
+          <a:solidFill>
+            <a:srgbClr val="0EA5E9"/>
+          </a:solidFill>
+          <a:ln>
+            <a:noFill/>
+          </a:ln>
+        </p:spPr>
+        <p:style>
+          <a:lnRef idx="1">
+            <a:schemeClr val="accent1"/>
+          </a:lnRef>
+          <a:fillRef idx="3">
+            <a:schemeClr val="accent1"/>
+          </a:fillRef>
+          <a:effectRef idx="2">
+            <a:schemeClr val="accent1"/>
+          </a:effectRef>
+          <a:fontRef idx="minor">
+            <a:schemeClr val="lt1"/>
+          </a:fontRef>
+        </p:style>
+        <p:txBody>
+          <a:bodyPr rtlCol="0" anchor="ctr"/>
+          <a:lstStyle/>
+          <a:p>
+            <a:pPr algn="ctr"/>
+          </a:p>
+        </p:txBody>
+      </p:sp>
+      <p:sp>
+        <p:nvSpPr>
+          <p:cNvPr id="4" name="Rectangle 3"/>
+          <p:cNvSpPr/>
+          <p:nvPr/>
+        </p:nvSpPr>
+        <p:spPr>
+          <a:xfrm>
+            <a:off x="11649456" y="384048"/>
+            <a:ext cx="118872" cy="118872"/>
+          </a:xfrm>
+          <a:prstGeom prst="rect">
+            <a:avLst/>
+          </a:prstGeom>
+          <a:solidFill>
+            <a:srgbClr val="F97316"/>
+          </a:solidFill>
+          <a:ln>
+            <a:noFill/>
+          </a:ln>
+        </p:spPr>
+        <p:style>
+          <a:lnRef idx="1">
+            <a:schemeClr val="accent1"/>
+          </a:lnRef>
+          <a:fillRef idx="3">
+            <a:schemeClr val="accent1"/>
+          </a:fillRef>
+          <a:effectRef idx="2">
+            <a:schemeClr val="accent1"/>
+          </a:effectRef>
+          <a:fontRef idx="minor">
+            <a:schemeClr val="lt1"/>
+          </a:fontRef>
+        </p:style>
+        <p:txBody>
+          <a:bodyPr rtlCol="0" anchor="ctr"/>
+          <a:lstStyle/>
+          <a:p>
+            <a:pPr algn="ctr"/>
+          </a:p>
+        </p:txBody>
+      </p:sp>
+      <p:sp>
+        <p:nvSpPr>
+          <p:cNvPr id="5" name="TextBox 4"/>
+          <p:cNvSpPr txBox="1"/>
+          <p:nvPr/>
+        </p:nvSpPr>
+        <p:spPr>
+          <a:xfrm>
+            <a:off x="502920" y="6510528"/>
+            <a:ext cx="4572000" cy="274320"/>
+          </a:xfrm>
+          <a:prstGeom prst="rect">
+            <a:avLst/>
+          </a:prstGeom>
+          <a:noFill/>
+        </p:spPr>
+        <p:txBody>
+          <a:bodyPr wrap="none">
+            <a:spAutoFit/>
+          </a:bodyPr>
+          <a:lstStyle/>
+          <a:p>
+            <a:r>
+              <a:rPr sz="800" b="0">
+                <a:solidFill>
+                  <a:srgbClr val="8FA3BC"/>
+                </a:solidFill>
+                <a:latin typeface="Calibri"/>
+              </a:rPr>
+              <a:t>Vibe Coding  ·  June 26, 2026</a:t>
+            </a:r>
+          </a:p>
+        </p:txBody>
+      </p:sp>
+      <p:sp>
+        <p:nvSpPr>
+          <p:cNvPr id="6" name="TextBox 5"/>
+          <p:cNvSpPr txBox="1"/>
+          <p:nvPr/>
+        </p:nvSpPr>
+        <p:spPr>
+          <a:xfrm>
+            <a:off x="502920" y="292608"/>
+            <a:ext cx="8229600" cy="274320"/>
+          </a:xfrm>
+          <a:prstGeom prst="rect">
+            <a:avLst/>
+          </a:prstGeom>
+          <a:noFill/>
+        </p:spPr>
+        <p:txBody>
+          <a:bodyPr wrap="none">
+            <a:spAutoFit/>
+          </a:bodyPr>
+          <a:lstStyle/>
+          <a:p>
+            <a:r>
+              <a:rPr sz="1050" b="1">
+                <a:solidFill>
+                  <a:srgbClr val="0284C7"/>
+                </a:solidFill>
+                <a:latin typeface="Arial"/>
+              </a:rPr>
+              <a:t>THE REALITY</a:t>
+            </a:r>
+          </a:p>
+        </p:txBody>
+      </p:sp>
+      <p:sp>
+        <p:nvSpPr>
+          <p:cNvPr id="7" name="TextBox 6"/>
+          <p:cNvSpPr txBox="1"/>
+          <p:nvPr/>
+        </p:nvSpPr>
+        <p:spPr>
+          <a:xfrm>
+            <a:off x="502920" y="530352"/>
+            <a:ext cx="10241280" cy="640080"/>
+          </a:xfrm>
+          <a:prstGeom prst="rect">
+            <a:avLst/>
+          </a:prstGeom>
+          <a:noFill/>
+        </p:spPr>
+        <p:txBody>
+          <a:bodyPr wrap="none">
+            <a:spAutoFit/>
+          </a:bodyPr>
+          <a:lstStyle/>
+          <a:p>
+            <a:r>
+              <a:rPr sz="2700" b="0">
+                <a:solidFill>
+                  <a:srgbClr val="0F2740"/>
+                </a:solidFill>
+                <a:latin typeface="Arial Black"/>
+              </a:rPr>
+              <a:t>How Do You Use AI Today?</a:t>
+            </a:r>
+          </a:p>
+        </p:txBody>
+      </p:sp>
+      <p:sp>
+        <p:nvSpPr>
+          <p:cNvPr id="8" name="Rounded Rectangle 7"/>
+          <p:cNvSpPr/>
+          <p:nvPr/>
+        </p:nvSpPr>
+        <p:spPr>
+          <a:xfrm>
+            <a:off x="502920" y="1600200"/>
+            <a:ext cx="4572000" cy="3657600"/>
+          </a:xfrm>
+          <a:prstGeom prst="roundRect">
+            <a:avLst/>
+          </a:prstGeom>
+          <a:solidFill>
+            <a:srgbClr val="FFFFFF"/>
+          </a:solidFill>
+          <a:ln w="12700">
+            <a:solidFill>
+              <a:srgbClr val="DCE6F0"/>
+            </a:solidFill>
+          </a:ln>
+        </p:spPr>
+        <p:style>
+          <a:lnRef idx="1">
+            <a:schemeClr val="accent1"/>
+          </a:lnRef>
+          <a:fillRef idx="3">
+            <a:schemeClr val="accent1"/>
+          </a:fillRef>
+          <a:effectRef idx="2">
+            <a:schemeClr val="accent1"/>
+          </a:effectRef>
+          <a:fontRef idx="minor">
+            <a:schemeClr val="lt1"/>
+          </a:fontRef>
+        </p:style>
+        <p:txBody>
+          <a:bodyPr rtlCol="0" anchor="ctr" lIns="355600" rIns="355600" tIns="304800" wrap="square"/>
+          <a:lstStyle/>
+          <a:p>
+            <a:pPr algn="ctr"/>
+            <a:r>
+              <a:rPr sz="1800" b="1">
+                <a:solidFill>
+                  <a:srgbClr val="0F2740"/>
+                </a:solidFill>
+                <a:latin typeface="Arial Black"/>
+              </a:rPr>
+              <a:t>The usual loop</a:t>
+            </a:r>
+          </a:p>
+          <a:p>
+            <a:pPr>
+              <a:spcBef>
+                <a:spcPts val="600"/>
+              </a:spcBef>
+            </a:pPr>
+            <a:r>
+              <a:rPr sz="1600" b="0">
+                <a:solidFill>
+                  <a:srgbClr val="47566B"/>
+                </a:solidFill>
+                <a:latin typeface="Calibri"/>
+              </a:rPr>
+              <a:t/>
+            </a:r>
+          </a:p>
+          <a:p>
+            <a:pPr>
+              <a:spcBef>
+                <a:spcPts val="600"/>
+              </a:spcBef>
+            </a:pPr>
+            <a:r>
+              <a:rPr sz="1600" b="1">
+                <a:solidFill>
+                  <a:srgbClr val="0284C7"/>
+                </a:solidFill>
+                <a:latin typeface="Calibri"/>
+              </a:rPr>
+              <a:t>1.  Write a simple prompt</a:t>
+            </a:r>
+          </a:p>
+          <a:p>
+            <a:pPr>
+              <a:spcBef>
+                <a:spcPts val="600"/>
+              </a:spcBef>
+            </a:pPr>
+            <a:r>
+              <a:rPr sz="1600" b="1">
+                <a:solidFill>
+                  <a:srgbClr val="0284C7"/>
+                </a:solidFill>
+                <a:latin typeface="Calibri"/>
+              </a:rPr>
+              <a:t>2.  Run it</a:t>
+            </a:r>
+          </a:p>
+          <a:p>
+            <a:pPr>
+              <a:spcBef>
+                <a:spcPts val="600"/>
+              </a:spcBef>
+            </a:pPr>
+            <a:r>
+              <a:rPr sz="1600" b="1">
+                <a:solidFill>
+                  <a:srgbClr val="0284C7"/>
+                </a:solidFill>
+                <a:latin typeface="Calibri"/>
+              </a:rPr>
+              <a:t>3.  Something breaks</a:t>
+            </a:r>
+          </a:p>
+          <a:p>
+            <a:pPr>
+              <a:spcBef>
+                <a:spcPts val="600"/>
+              </a:spcBef>
+            </a:pPr>
+            <a:r>
+              <a:rPr sz="1600" b="1">
+                <a:solidFill>
+                  <a:srgbClr val="0284C7"/>
+                </a:solidFill>
+                <a:latin typeface="Calibri"/>
+              </a:rPr>
+              <a:t>4.  Patch with another prompt</a:t>
+            </a:r>
+          </a:p>
+          <a:p>
+            <a:pPr>
+              <a:spcBef>
+                <a:spcPts val="600"/>
+              </a:spcBef>
+            </a:pPr>
+            <a:r>
+              <a:rPr sz="1600" b="1">
+                <a:solidFill>
+                  <a:srgbClr val="0284C7"/>
+                </a:solidFill>
+                <a:latin typeface="Calibri"/>
+              </a:rPr>
+              <a:t>5.  Repeat…</a:t>
+            </a:r>
+          </a:p>
+        </p:txBody>
+      </p:sp>
+      <p:sp>
+        <p:nvSpPr>
+          <p:cNvPr id="9" name="TextBox 8"/>
+          <p:cNvSpPr txBox="1"/>
+          <p:nvPr/>
+        </p:nvSpPr>
+        <p:spPr>
+          <a:xfrm>
+            <a:off x="5486400" y="1691640"/>
+            <a:ext cx="6035040" cy="457200"/>
+          </a:xfrm>
+          <a:prstGeom prst="rect">
+            <a:avLst/>
+          </a:prstGeom>
+          <a:noFill/>
+        </p:spPr>
+        <p:txBody>
+          <a:bodyPr wrap="none">
+            <a:spAutoFit/>
+          </a:bodyPr>
+          <a:lstStyle/>
+          <a:p>
+            <a:r>
+              <a:rPr sz="1600" b="1">
+                <a:solidFill>
+                  <a:srgbClr val="0F2740"/>
+                </a:solidFill>
+                <a:latin typeface="Calibri"/>
+              </a:rPr>
+              <a:t>Most people never leave step 1.</a:t>
+            </a:r>
+          </a:p>
+        </p:txBody>
+      </p:sp>
+      <p:sp>
+        <p:nvSpPr>
+          <p:cNvPr id="10" name="TextBox 9"/>
+          <p:cNvSpPr txBox="1"/>
+          <p:nvPr/>
+        </p:nvSpPr>
+        <p:spPr>
+          <a:xfrm>
+            <a:off x="5486400" y="2194560"/>
+            <a:ext cx="6035040" cy="2926080"/>
+          </a:xfrm>
+          <a:prstGeom prst="rect">
+            <a:avLst/>
+          </a:prstGeom>
+          <a:noFill/>
+        </p:spPr>
+        <p:txBody>
+          <a:bodyPr wrap="square">
+            <a:spAutoFit/>
+          </a:bodyPr>
+          <a:lstStyle/>
+          <a:p>
+            <a:pPr>
+              <a:spcBef>
+                <a:spcPts val="1000"/>
+              </a:spcBef>
+            </a:pPr>
+            <a:r>
+              <a:rPr sz="1350" b="0">
+                <a:solidFill>
+                  <a:srgbClr val="47566B"/>
+                </a:solidFill>
+                <a:latin typeface="Calibri"/>
+              </a:rPr>
+              <a:t>•  That workflow delivers a quick demo — not a real engineering project.</a:t>
+            </a:r>
+          </a:p>
+          <a:p>
+            <a:pPr>
+              <a:spcBef>
+                <a:spcPts val="1000"/>
+              </a:spcBef>
+            </a:pPr>
+            <a:r>
+              <a:rPr sz="1350" b="0">
+                <a:solidFill>
+                  <a:srgbClr val="47566B"/>
+                </a:solidFill>
+                <a:latin typeface="Calibri"/>
+              </a:rPr>
+              <a:t>•  Complex systems have many modules and tangled dependencies.</a:t>
+            </a:r>
+          </a:p>
+          <a:p>
+            <a:pPr>
+              <a:spcBef>
+                <a:spcPts val="1000"/>
+              </a:spcBef>
+            </a:pPr>
+            <a:r>
+              <a:rPr sz="1350" b="0">
+                <a:solidFill>
+                  <a:srgbClr val="47566B"/>
+                </a:solidFill>
+                <a:latin typeface="Calibri"/>
+              </a:rPr>
+              <a:t>•  Change one part without a plan → fix east, break west.</a:t>
+            </a:r>
+          </a:p>
+          <a:p>
+            <a:pPr>
+              <a:spcBef>
+                <a:spcPts val="1000"/>
+              </a:spcBef>
+            </a:pPr>
+            <a:r>
+              <a:rPr sz="1350" b="0">
+                <a:solidFill>
+                  <a:srgbClr val="47566B"/>
+                </a:solidFill>
+                <a:latin typeface="Calibri"/>
+              </a:rPr>
+              <a:t>•  Prompts without design don't scale — they just move the bug around.</a:t>
+            </a:r>
+          </a:p>
+          <a:p>
+            <a:pPr>
+              <a:spcBef>
+                <a:spcPts val="1000"/>
+              </a:spcBef>
+            </a:pPr>
+            <a:r>
+              <a:rPr sz="1350" b="0">
+                <a:solidFill>
+                  <a:srgbClr val="47566B"/>
+                </a:solidFill>
+                <a:latin typeface="Calibri"/>
+              </a:rPr>
+              <a:t>•  AI is getting stronger, but it still can't replace structure.</a:t>
+            </a:r>
+          </a:p>
+        </p:txBody>
+      </p:sp>
+      <p:sp>
+        <p:nvSpPr>
+          <p:cNvPr id="11" name="TextBox 10"/>
+          <p:cNvSpPr txBox="1"/>
+          <p:nvPr/>
+        </p:nvSpPr>
+        <p:spPr>
+          <a:xfrm>
+            <a:off x="502920" y="5669280"/>
+            <a:ext cx="11155680" cy="320040"/>
+          </a:xfrm>
+          <a:prstGeom prst="rect">
+            <a:avLst/>
+          </a:prstGeom>
+          <a:noFill/>
+        </p:spPr>
+        <p:txBody>
+          <a:bodyPr wrap="none">
+            <a:spAutoFit/>
+          </a:bodyPr>
+          <a:lstStyle/>
+          <a:p>
+            <a:r>
+              <a:rPr sz="1250" b="1">
+                <a:solidFill>
+                  <a:srgbClr val="F97316"/>
+                </a:solidFill>
+                <a:latin typeface="Calibri"/>
+              </a:rPr>
+              <a:t>A stronger model </a:t>
+            </a:r>
+            <a:r>
+              <a:rPr sz="1250" b="0">
+                <a:solidFill>
+                  <a:srgbClr val="47566B"/>
+                </a:solidFill>
+                <a:latin typeface="Calibri"/>
+              </a:rPr>
+              <a:t>doesn't fix a missing plan.</a:t>
+            </a:r>
           </a:p>
         </p:txBody>
       </p:sp>

</xml_diff>